<commit_message>
almost finished first chapter. close to finish the second. images almost all done. todo fix sentences and make the flow running
</commit_message>
<xml_diff>
--- a/chapter_introduction/figures/cnt_device.pptx
+++ b/chapter_introduction/figures/cnt_device.pptx
@@ -5,7 +5,9 @@
     <p:sldMasterId id="2147483696" r:id="rId1"/>
   </p:sldMasterIdLst>
   <p:sldIdLst>
-    <p:sldId id="256" r:id="rId2"/>
+    <p:sldId id="257" r:id="rId2"/>
+    <p:sldId id="258" r:id="rId3"/>
+    <p:sldId id="256" r:id="rId4"/>
   </p:sldIdLst>
   <p:sldSz cx="5040313" cy="6480175"/>
   <p:notesSz cx="6858000" cy="9144000"/>
@@ -154,7 +156,7 @@
           </a:lstStyle>
           <a:p>
             <a:r>
-              <a:rPr lang="en-US" smtClean="0"/>
+              <a:rPr lang="en-US"/>
               <a:t>Click to edit Master title style</a:t>
             </a:r>
             <a:endParaRPr lang="en-US" dirty="0"/>
@@ -219,7 +221,7 @@
           </a:lstStyle>
           <a:p>
             <a:r>
-              <a:rPr lang="en-US" smtClean="0"/>
+              <a:rPr lang="en-US"/>
               <a:t>Click to edit Master subtitle style</a:t>
             </a:r>
             <a:endParaRPr lang="en-US" dirty="0"/>
@@ -243,7 +245,7 @@
           <a:p>
             <a:fld id="{E2AFB575-D6AB-47CF-9E00-E51589758BC6}" type="datetimeFigureOut">
               <a:rPr lang="en-GB" smtClean="0"/>
-              <a:t>17/03/2022</a:t>
+              <a:t>07/04/2022</a:t>
             </a:fld>
             <a:endParaRPr lang="en-GB"/>
           </a:p>
@@ -337,7 +339,7 @@
           <a:lstStyle/>
           <a:p>
             <a:r>
-              <a:rPr lang="en-US" smtClean="0"/>
+              <a:rPr lang="en-US"/>
               <a:t>Click to edit Master title style</a:t>
             </a:r>
             <a:endParaRPr lang="en-US" dirty="0"/>
@@ -361,35 +363,35 @@
           <a:p>
             <a:pPr lvl="0"/>
             <a:r>
-              <a:rPr lang="en-US" smtClean="0"/>
+              <a:rPr lang="en-US"/>
               <a:t>Edit Master text styles</a:t>
             </a:r>
           </a:p>
           <a:p>
             <a:pPr lvl="1"/>
             <a:r>
-              <a:rPr lang="en-US" smtClean="0"/>
+              <a:rPr lang="en-US"/>
               <a:t>Second level</a:t>
             </a:r>
           </a:p>
           <a:p>
             <a:pPr lvl="2"/>
             <a:r>
-              <a:rPr lang="en-US" smtClean="0"/>
+              <a:rPr lang="en-US"/>
               <a:t>Third level</a:t>
             </a:r>
           </a:p>
           <a:p>
             <a:pPr lvl="3"/>
             <a:r>
-              <a:rPr lang="en-US" smtClean="0"/>
+              <a:rPr lang="en-US"/>
               <a:t>Fourth level</a:t>
             </a:r>
           </a:p>
           <a:p>
             <a:pPr lvl="4"/>
             <a:r>
-              <a:rPr lang="en-US" smtClean="0"/>
+              <a:rPr lang="en-US"/>
               <a:t>Fifth level</a:t>
             </a:r>
             <a:endParaRPr lang="en-US" dirty="0"/>
@@ -413,7 +415,7 @@
           <a:p>
             <a:fld id="{E2AFB575-D6AB-47CF-9E00-E51589758BC6}" type="datetimeFigureOut">
               <a:rPr lang="en-GB" smtClean="0"/>
-              <a:t>17/03/2022</a:t>
+              <a:t>07/04/2022</a:t>
             </a:fld>
             <a:endParaRPr lang="en-GB"/>
           </a:p>
@@ -512,7 +514,7 @@
           <a:lstStyle/>
           <a:p>
             <a:r>
-              <a:rPr lang="en-US" smtClean="0"/>
+              <a:rPr lang="en-US"/>
               <a:t>Click to edit Master title style</a:t>
             </a:r>
             <a:endParaRPr lang="en-US" dirty="0"/>
@@ -541,35 +543,35 @@
           <a:p>
             <a:pPr lvl="0"/>
             <a:r>
-              <a:rPr lang="en-US" smtClean="0"/>
+              <a:rPr lang="en-US"/>
               <a:t>Edit Master text styles</a:t>
             </a:r>
           </a:p>
           <a:p>
             <a:pPr lvl="1"/>
             <a:r>
-              <a:rPr lang="en-US" smtClean="0"/>
+              <a:rPr lang="en-US"/>
               <a:t>Second level</a:t>
             </a:r>
           </a:p>
           <a:p>
             <a:pPr lvl="2"/>
             <a:r>
-              <a:rPr lang="en-US" smtClean="0"/>
+              <a:rPr lang="en-US"/>
               <a:t>Third level</a:t>
             </a:r>
           </a:p>
           <a:p>
             <a:pPr lvl="3"/>
             <a:r>
-              <a:rPr lang="en-US" smtClean="0"/>
+              <a:rPr lang="en-US"/>
               <a:t>Fourth level</a:t>
             </a:r>
           </a:p>
           <a:p>
             <a:pPr lvl="4"/>
             <a:r>
-              <a:rPr lang="en-US" smtClean="0"/>
+              <a:rPr lang="en-US"/>
               <a:t>Fifth level</a:t>
             </a:r>
             <a:endParaRPr lang="en-US" dirty="0"/>
@@ -593,7 +595,7 @@
           <a:p>
             <a:fld id="{E2AFB575-D6AB-47CF-9E00-E51589758BC6}" type="datetimeFigureOut">
               <a:rPr lang="en-GB" smtClean="0"/>
-              <a:t>17/03/2022</a:t>
+              <a:t>07/04/2022</a:t>
             </a:fld>
             <a:endParaRPr lang="en-GB"/>
           </a:p>
@@ -687,7 +689,7 @@
           <a:lstStyle/>
           <a:p>
             <a:r>
-              <a:rPr lang="en-US" smtClean="0"/>
+              <a:rPr lang="en-US"/>
               <a:t>Click to edit Master title style</a:t>
             </a:r>
             <a:endParaRPr lang="en-US" dirty="0"/>
@@ -711,35 +713,35 @@
           <a:p>
             <a:pPr lvl="0"/>
             <a:r>
-              <a:rPr lang="en-US" smtClean="0"/>
+              <a:rPr lang="en-US"/>
               <a:t>Edit Master text styles</a:t>
             </a:r>
           </a:p>
           <a:p>
             <a:pPr lvl="1"/>
             <a:r>
-              <a:rPr lang="en-US" smtClean="0"/>
+              <a:rPr lang="en-US"/>
               <a:t>Second level</a:t>
             </a:r>
           </a:p>
           <a:p>
             <a:pPr lvl="2"/>
             <a:r>
-              <a:rPr lang="en-US" smtClean="0"/>
+              <a:rPr lang="en-US"/>
               <a:t>Third level</a:t>
             </a:r>
           </a:p>
           <a:p>
             <a:pPr lvl="3"/>
             <a:r>
-              <a:rPr lang="en-US" smtClean="0"/>
+              <a:rPr lang="en-US"/>
               <a:t>Fourth level</a:t>
             </a:r>
           </a:p>
           <a:p>
             <a:pPr lvl="4"/>
             <a:r>
-              <a:rPr lang="en-US" smtClean="0"/>
+              <a:rPr lang="en-US"/>
               <a:t>Fifth level</a:t>
             </a:r>
             <a:endParaRPr lang="en-US" dirty="0"/>
@@ -763,7 +765,7 @@
           <a:p>
             <a:fld id="{E2AFB575-D6AB-47CF-9E00-E51589758BC6}" type="datetimeFigureOut">
               <a:rPr lang="en-GB" smtClean="0"/>
-              <a:t>17/03/2022</a:t>
+              <a:t>07/04/2022</a:t>
             </a:fld>
             <a:endParaRPr lang="en-GB"/>
           </a:p>
@@ -866,7 +868,7 @@
           </a:lstStyle>
           <a:p>
             <a:r>
-              <a:rPr lang="en-US" smtClean="0"/>
+              <a:rPr lang="en-US"/>
               <a:t>Click to edit Master title style</a:t>
             </a:r>
             <a:endParaRPr lang="en-US" dirty="0"/>
@@ -984,7 +986,7 @@
           <a:p>
             <a:pPr lvl="0"/>
             <a:r>
-              <a:rPr lang="en-US" smtClean="0"/>
+              <a:rPr lang="en-US"/>
               <a:t>Edit Master text styles</a:t>
             </a:r>
           </a:p>
@@ -1007,7 +1009,7 @@
           <a:p>
             <a:fld id="{E2AFB575-D6AB-47CF-9E00-E51589758BC6}" type="datetimeFigureOut">
               <a:rPr lang="en-GB" smtClean="0"/>
-              <a:t>17/03/2022</a:t>
+              <a:t>07/04/2022</a:t>
             </a:fld>
             <a:endParaRPr lang="en-GB"/>
           </a:p>
@@ -1101,7 +1103,7 @@
           <a:lstStyle/>
           <a:p>
             <a:r>
-              <a:rPr lang="en-US" smtClean="0"/>
+              <a:rPr lang="en-US"/>
               <a:t>Click to edit Master title style</a:t>
             </a:r>
             <a:endParaRPr lang="en-US" dirty="0"/>
@@ -1130,35 +1132,35 @@
           <a:p>
             <a:pPr lvl="0"/>
             <a:r>
-              <a:rPr lang="en-US" smtClean="0"/>
+              <a:rPr lang="en-US"/>
               <a:t>Edit Master text styles</a:t>
             </a:r>
           </a:p>
           <a:p>
             <a:pPr lvl="1"/>
             <a:r>
-              <a:rPr lang="en-US" smtClean="0"/>
+              <a:rPr lang="en-US"/>
               <a:t>Second level</a:t>
             </a:r>
           </a:p>
           <a:p>
             <a:pPr lvl="2"/>
             <a:r>
-              <a:rPr lang="en-US" smtClean="0"/>
+              <a:rPr lang="en-US"/>
               <a:t>Third level</a:t>
             </a:r>
           </a:p>
           <a:p>
             <a:pPr lvl="3"/>
             <a:r>
-              <a:rPr lang="en-US" smtClean="0"/>
+              <a:rPr lang="en-US"/>
               <a:t>Fourth level</a:t>
             </a:r>
           </a:p>
           <a:p>
             <a:pPr lvl="4"/>
             <a:r>
-              <a:rPr lang="en-US" smtClean="0"/>
+              <a:rPr lang="en-US"/>
               <a:t>Fifth level</a:t>
             </a:r>
             <a:endParaRPr lang="en-US" dirty="0"/>
@@ -1187,35 +1189,35 @@
           <a:p>
             <a:pPr lvl="0"/>
             <a:r>
-              <a:rPr lang="en-US" smtClean="0"/>
+              <a:rPr lang="en-US"/>
               <a:t>Edit Master text styles</a:t>
             </a:r>
           </a:p>
           <a:p>
             <a:pPr lvl="1"/>
             <a:r>
-              <a:rPr lang="en-US" smtClean="0"/>
+              <a:rPr lang="en-US"/>
               <a:t>Second level</a:t>
             </a:r>
           </a:p>
           <a:p>
             <a:pPr lvl="2"/>
             <a:r>
-              <a:rPr lang="en-US" smtClean="0"/>
+              <a:rPr lang="en-US"/>
               <a:t>Third level</a:t>
             </a:r>
           </a:p>
           <a:p>
             <a:pPr lvl="3"/>
             <a:r>
-              <a:rPr lang="en-US" smtClean="0"/>
+              <a:rPr lang="en-US"/>
               <a:t>Fourth level</a:t>
             </a:r>
           </a:p>
           <a:p>
             <a:pPr lvl="4"/>
             <a:r>
-              <a:rPr lang="en-US" smtClean="0"/>
+              <a:rPr lang="en-US"/>
               <a:t>Fifth level</a:t>
             </a:r>
             <a:endParaRPr lang="en-US" dirty="0"/>
@@ -1239,7 +1241,7 @@
           <a:p>
             <a:fld id="{E2AFB575-D6AB-47CF-9E00-E51589758BC6}" type="datetimeFigureOut">
               <a:rPr lang="en-GB" smtClean="0"/>
-              <a:t>17/03/2022</a:t>
+              <a:t>07/04/2022</a:t>
             </a:fld>
             <a:endParaRPr lang="en-GB"/>
           </a:p>
@@ -1338,7 +1340,7 @@
           <a:lstStyle/>
           <a:p>
             <a:r>
-              <a:rPr lang="en-US" smtClean="0"/>
+              <a:rPr lang="en-US"/>
               <a:t>Click to edit Master title style</a:t>
             </a:r>
             <a:endParaRPr lang="en-US" dirty="0"/>
@@ -1404,7 +1406,7 @@
           <a:p>
             <a:pPr lvl="0"/>
             <a:r>
-              <a:rPr lang="en-US" smtClean="0"/>
+              <a:rPr lang="en-US"/>
               <a:t>Edit Master text styles</a:t>
             </a:r>
           </a:p>
@@ -1432,35 +1434,35 @@
           <a:p>
             <a:pPr lvl="0"/>
             <a:r>
-              <a:rPr lang="en-US" smtClean="0"/>
+              <a:rPr lang="en-US"/>
               <a:t>Edit Master text styles</a:t>
             </a:r>
           </a:p>
           <a:p>
             <a:pPr lvl="1"/>
             <a:r>
-              <a:rPr lang="en-US" smtClean="0"/>
+              <a:rPr lang="en-US"/>
               <a:t>Second level</a:t>
             </a:r>
           </a:p>
           <a:p>
             <a:pPr lvl="2"/>
             <a:r>
-              <a:rPr lang="en-US" smtClean="0"/>
+              <a:rPr lang="en-US"/>
               <a:t>Third level</a:t>
             </a:r>
           </a:p>
           <a:p>
             <a:pPr lvl="3"/>
             <a:r>
-              <a:rPr lang="en-US" smtClean="0"/>
+              <a:rPr lang="en-US"/>
               <a:t>Fourth level</a:t>
             </a:r>
           </a:p>
           <a:p>
             <a:pPr lvl="4"/>
             <a:r>
-              <a:rPr lang="en-US" smtClean="0"/>
+              <a:rPr lang="en-US"/>
               <a:t>Fifth level</a:t>
             </a:r>
             <a:endParaRPr lang="en-US" dirty="0"/>
@@ -1526,7 +1528,7 @@
           <a:p>
             <a:pPr lvl="0"/>
             <a:r>
-              <a:rPr lang="en-US" smtClean="0"/>
+              <a:rPr lang="en-US"/>
               <a:t>Edit Master text styles</a:t>
             </a:r>
           </a:p>
@@ -1554,35 +1556,35 @@
           <a:p>
             <a:pPr lvl="0"/>
             <a:r>
-              <a:rPr lang="en-US" smtClean="0"/>
+              <a:rPr lang="en-US"/>
               <a:t>Edit Master text styles</a:t>
             </a:r>
           </a:p>
           <a:p>
             <a:pPr lvl="1"/>
             <a:r>
-              <a:rPr lang="en-US" smtClean="0"/>
+              <a:rPr lang="en-US"/>
               <a:t>Second level</a:t>
             </a:r>
           </a:p>
           <a:p>
             <a:pPr lvl="2"/>
             <a:r>
-              <a:rPr lang="en-US" smtClean="0"/>
+              <a:rPr lang="en-US"/>
               <a:t>Third level</a:t>
             </a:r>
           </a:p>
           <a:p>
             <a:pPr lvl="3"/>
             <a:r>
-              <a:rPr lang="en-US" smtClean="0"/>
+              <a:rPr lang="en-US"/>
               <a:t>Fourth level</a:t>
             </a:r>
           </a:p>
           <a:p>
             <a:pPr lvl="4"/>
             <a:r>
-              <a:rPr lang="en-US" smtClean="0"/>
+              <a:rPr lang="en-US"/>
               <a:t>Fifth level</a:t>
             </a:r>
             <a:endParaRPr lang="en-US" dirty="0"/>
@@ -1606,7 +1608,7 @@
           <a:p>
             <a:fld id="{E2AFB575-D6AB-47CF-9E00-E51589758BC6}" type="datetimeFigureOut">
               <a:rPr lang="en-GB" smtClean="0"/>
-              <a:t>17/03/2022</a:t>
+              <a:t>07/04/2022</a:t>
             </a:fld>
             <a:endParaRPr lang="en-GB"/>
           </a:p>
@@ -1700,7 +1702,7 @@
           <a:lstStyle/>
           <a:p>
             <a:r>
-              <a:rPr lang="en-US" smtClean="0"/>
+              <a:rPr lang="en-US"/>
               <a:t>Click to edit Master title style</a:t>
             </a:r>
             <a:endParaRPr lang="en-US" dirty="0"/>
@@ -1724,7 +1726,7 @@
           <a:p>
             <a:fld id="{E2AFB575-D6AB-47CF-9E00-E51589758BC6}" type="datetimeFigureOut">
               <a:rPr lang="en-GB" smtClean="0"/>
-              <a:t>17/03/2022</a:t>
+              <a:t>07/04/2022</a:t>
             </a:fld>
             <a:endParaRPr lang="en-GB"/>
           </a:p>
@@ -1819,7 +1821,7 @@
           <a:p>
             <a:fld id="{E2AFB575-D6AB-47CF-9E00-E51589758BC6}" type="datetimeFigureOut">
               <a:rPr lang="en-GB" smtClean="0"/>
-              <a:t>17/03/2022</a:t>
+              <a:t>07/04/2022</a:t>
             </a:fld>
             <a:endParaRPr lang="en-GB"/>
           </a:p>
@@ -1922,7 +1924,7 @@
           </a:lstStyle>
           <a:p>
             <a:r>
-              <a:rPr lang="en-US" smtClean="0"/>
+              <a:rPr lang="en-US"/>
               <a:t>Click to edit Master title style</a:t>
             </a:r>
             <a:endParaRPr lang="en-US" dirty="0"/>
@@ -1979,35 +1981,35 @@
           <a:p>
             <a:pPr lvl="0"/>
             <a:r>
-              <a:rPr lang="en-US" smtClean="0"/>
+              <a:rPr lang="en-US"/>
               <a:t>Edit Master text styles</a:t>
             </a:r>
           </a:p>
           <a:p>
             <a:pPr lvl="1"/>
             <a:r>
-              <a:rPr lang="en-US" smtClean="0"/>
+              <a:rPr lang="en-US"/>
               <a:t>Second level</a:t>
             </a:r>
           </a:p>
           <a:p>
             <a:pPr lvl="2"/>
             <a:r>
-              <a:rPr lang="en-US" smtClean="0"/>
+              <a:rPr lang="en-US"/>
               <a:t>Third level</a:t>
             </a:r>
           </a:p>
           <a:p>
             <a:pPr lvl="3"/>
             <a:r>
-              <a:rPr lang="en-US" smtClean="0"/>
+              <a:rPr lang="en-US"/>
               <a:t>Fourth level</a:t>
             </a:r>
           </a:p>
           <a:p>
             <a:pPr lvl="4"/>
             <a:r>
-              <a:rPr lang="en-US" smtClean="0"/>
+              <a:rPr lang="en-US"/>
               <a:t>Fifth level</a:t>
             </a:r>
             <a:endParaRPr lang="en-US" dirty="0"/>
@@ -2073,7 +2075,7 @@
           <a:p>
             <a:pPr lvl="0"/>
             <a:r>
-              <a:rPr lang="en-US" smtClean="0"/>
+              <a:rPr lang="en-US"/>
               <a:t>Edit Master text styles</a:t>
             </a:r>
           </a:p>
@@ -2096,7 +2098,7 @@
           <a:p>
             <a:fld id="{E2AFB575-D6AB-47CF-9E00-E51589758BC6}" type="datetimeFigureOut">
               <a:rPr lang="en-GB" smtClean="0"/>
-              <a:t>17/03/2022</a:t>
+              <a:t>07/04/2022</a:t>
             </a:fld>
             <a:endParaRPr lang="en-GB"/>
           </a:p>
@@ -2199,7 +2201,7 @@
           </a:lstStyle>
           <a:p>
             <a:r>
-              <a:rPr lang="en-US" smtClean="0"/>
+              <a:rPr lang="en-US"/>
               <a:t>Click to edit Master title style</a:t>
             </a:r>
             <a:endParaRPr lang="en-US" dirty="0"/>
@@ -2264,7 +2266,7 @@
           </a:lstStyle>
           <a:p>
             <a:r>
-              <a:rPr lang="en-US" smtClean="0"/>
+              <a:rPr lang="en-US"/>
               <a:t>Click icon to add picture</a:t>
             </a:r>
             <a:endParaRPr lang="en-US" dirty="0"/>
@@ -2330,7 +2332,7 @@
           <a:p>
             <a:pPr lvl="0"/>
             <a:r>
-              <a:rPr lang="en-US" smtClean="0"/>
+              <a:rPr lang="en-US"/>
               <a:t>Edit Master text styles</a:t>
             </a:r>
           </a:p>
@@ -2353,7 +2355,7 @@
           <a:p>
             <a:fld id="{E2AFB575-D6AB-47CF-9E00-E51589758BC6}" type="datetimeFigureOut">
               <a:rPr lang="en-GB" smtClean="0"/>
-              <a:t>17/03/2022</a:t>
+              <a:t>07/04/2022</a:t>
             </a:fld>
             <a:endParaRPr lang="en-GB"/>
           </a:p>
@@ -2462,7 +2464,7 @@
           <a:lstStyle/>
           <a:p>
             <a:r>
-              <a:rPr lang="en-US" smtClean="0"/>
+              <a:rPr lang="en-US"/>
               <a:t>Click to edit Master title style</a:t>
             </a:r>
             <a:endParaRPr lang="en-US" dirty="0"/>
@@ -2496,35 +2498,35 @@
           <a:p>
             <a:pPr lvl="0"/>
             <a:r>
-              <a:rPr lang="en-US" smtClean="0"/>
+              <a:rPr lang="en-US"/>
               <a:t>Edit Master text styles</a:t>
             </a:r>
           </a:p>
           <a:p>
             <a:pPr lvl="1"/>
             <a:r>
-              <a:rPr lang="en-US" smtClean="0"/>
+              <a:rPr lang="en-US"/>
               <a:t>Second level</a:t>
             </a:r>
           </a:p>
           <a:p>
             <a:pPr lvl="2"/>
             <a:r>
-              <a:rPr lang="en-US" smtClean="0"/>
+              <a:rPr lang="en-US"/>
               <a:t>Third level</a:t>
             </a:r>
           </a:p>
           <a:p>
             <a:pPr lvl="3"/>
             <a:r>
-              <a:rPr lang="en-US" smtClean="0"/>
+              <a:rPr lang="en-US"/>
               <a:t>Fourth level</a:t>
             </a:r>
           </a:p>
           <a:p>
             <a:pPr lvl="4"/>
             <a:r>
-              <a:rPr lang="en-US" smtClean="0"/>
+              <a:rPr lang="en-US"/>
               <a:t>Fifth level</a:t>
             </a:r>
             <a:endParaRPr lang="en-US" dirty="0"/>
@@ -2566,7 +2568,7 @@
           <a:p>
             <a:fld id="{E2AFB575-D6AB-47CF-9E00-E51589758BC6}" type="datetimeFigureOut">
               <a:rPr lang="en-GB" smtClean="0"/>
-              <a:t>17/03/2022</a:t>
+              <a:t>07/04/2022</a:t>
             </a:fld>
             <a:endParaRPr lang="en-GB"/>
           </a:p>
@@ -2973,16 +2975,22 @@
       </p:grpSpPr>
       <p:grpSp>
         <p:nvGrpSpPr>
-          <p:cNvPr id="3" name="Group 2"/>
+          <p:cNvPr id="4" name="Group 3">
+            <a:extLst>
+              <a:ext uri="{FF2B5EF4-FFF2-40B4-BE49-F238E27FC236}">
+                <a16:creationId xmlns:a16="http://schemas.microsoft.com/office/drawing/2014/main" id="{7BBA1383-B1D4-43EE-BE21-2E1ECE97C521}"/>
+              </a:ext>
+            </a:extLst>
+          </p:cNvPr>
           <p:cNvGrpSpPr/>
           <p:nvPr/>
         </p:nvGrpSpPr>
         <p:grpSpPr>
           <a:xfrm>
-            <a:off x="170691" y="250747"/>
-            <a:ext cx="4661324" cy="5322887"/>
-            <a:chOff x="-169294" y="331773"/>
-            <a:chExt cx="7026542" cy="8023782"/>
+            <a:off x="289228" y="284614"/>
+            <a:ext cx="4273102" cy="3527767"/>
+            <a:chOff x="170695" y="250747"/>
+            <a:chExt cx="4273102" cy="3527767"/>
           </a:xfrm>
         </p:grpSpPr>
         <p:pic>
@@ -3001,8 +3009,8 @@
           </p:blipFill>
           <p:spPr>
             <a:xfrm>
-              <a:off x="3517988" y="2484420"/>
-              <a:ext cx="2602365" cy="1927227"/>
+              <a:off x="2185760" y="2106283"/>
+              <a:ext cx="2258037" cy="1672231"/>
             </a:xfrm>
             <a:prstGeom prst="rect">
               <a:avLst/>
@@ -3025,8 +3033,8 @@
           </p:blipFill>
           <p:spPr>
             <a:xfrm>
-              <a:off x="518874" y="2689752"/>
-              <a:ext cx="2114890" cy="1013618"/>
+              <a:off x="596516" y="2494298"/>
+              <a:ext cx="1604054" cy="768787"/>
             </a:xfrm>
             <a:prstGeom prst="rect">
               <a:avLst/>
@@ -3035,99 +3043,14 @@
         </p:pic>
         <p:grpSp>
           <p:nvGrpSpPr>
-            <p:cNvPr id="8" name="Group 7"/>
-            <p:cNvGrpSpPr/>
-            <p:nvPr/>
-          </p:nvGrpSpPr>
-          <p:grpSpPr>
-            <a:xfrm>
-              <a:off x="50384" y="4483089"/>
-              <a:ext cx="2673523" cy="1109866"/>
-              <a:chOff x="8348257" y="1485049"/>
-              <a:chExt cx="3284297" cy="1467834"/>
-            </a:xfrm>
-          </p:grpSpPr>
-          <p:pic>
-            <p:nvPicPr>
-              <p:cNvPr id="14" name="Picture 13"/>
-              <p:cNvPicPr>
-                <a:picLocks noChangeAspect="1"/>
-              </p:cNvPicPr>
-              <p:nvPr/>
-            </p:nvPicPr>
-            <p:blipFill>
-              <a:blip r:embed="rId4"/>
-              <a:stretch>
-                <a:fillRect/>
-              </a:stretch>
-            </p:blipFill>
-            <p:spPr>
-              <a:xfrm>
-                <a:off x="8522824" y="1599319"/>
-                <a:ext cx="3109730" cy="1353564"/>
-              </a:xfrm>
-              <a:prstGeom prst="rect">
-                <a:avLst/>
-              </a:prstGeom>
-            </p:spPr>
-          </p:pic>
-          <p:sp>
-            <p:nvSpPr>
-              <p:cNvPr id="15" name="Rectangle 14"/>
-              <p:cNvSpPr/>
-              <p:nvPr/>
-            </p:nvSpPr>
-            <p:spPr>
-              <a:xfrm>
-                <a:off x="8348257" y="1485049"/>
-                <a:ext cx="349134" cy="349134"/>
-              </a:xfrm>
-              <a:prstGeom prst="rect">
-                <a:avLst/>
-              </a:prstGeom>
-              <a:solidFill>
-                <a:schemeClr val="bg1"/>
-              </a:solidFill>
-              <a:ln>
-                <a:noFill/>
-              </a:ln>
-            </p:spPr>
-            <p:style>
-              <a:lnRef idx="2">
-                <a:schemeClr val="accent1">
-                  <a:shade val="50000"/>
-                </a:schemeClr>
-              </a:lnRef>
-              <a:fillRef idx="1">
-                <a:schemeClr val="accent1"/>
-              </a:fillRef>
-              <a:effectRef idx="0">
-                <a:schemeClr val="accent1"/>
-              </a:effectRef>
-              <a:fontRef idx="minor">
-                <a:schemeClr val="lt1"/>
-              </a:fontRef>
-            </p:style>
-            <p:txBody>
-              <a:bodyPr rtlCol="0" anchor="ctr"/>
-              <a:lstStyle/>
-              <a:p>
-                <a:pPr algn="ctr"/>
-                <a:endParaRPr lang="en-GB" sz="2113"/>
-              </a:p>
-            </p:txBody>
-          </p:sp>
-        </p:grpSp>
-        <p:grpSp>
-          <p:nvGrpSpPr>
             <p:cNvPr id="9" name="Group 8"/>
             <p:cNvGrpSpPr/>
             <p:nvPr/>
           </p:nvGrpSpPr>
           <p:grpSpPr>
             <a:xfrm>
-              <a:off x="434995" y="711081"/>
-              <a:ext cx="2282649" cy="1605847"/>
+              <a:off x="257515" y="605946"/>
+              <a:ext cx="2002799" cy="1408974"/>
               <a:chOff x="686712" y="1517950"/>
               <a:chExt cx="2293013" cy="1736679"/>
             </a:xfrm>
@@ -3155,7 +3078,7 @@
                 <p:nvPr/>
               </p:nvPicPr>
               <p:blipFill rotWithShape="1">
-                <a:blip r:embed="rId5" cstate="print">
+                <a:blip r:embed="rId4" cstate="print">
                   <a:extLst>
                     <a:ext uri="{28A0092B-C50C-407E-A947-70E740481C1C}">
                       <a14:useLocalDpi xmlns:a14="http://schemas.microsoft.com/office/drawing/2010/main" val="0"/>
@@ -3287,8 +3210,8 @@
           </p:nvSpPr>
           <p:spPr>
             <a:xfrm>
-              <a:off x="-163168" y="331773"/>
-              <a:ext cx="643243" cy="629325"/>
+              <a:off x="174755" y="250747"/>
+              <a:ext cx="343364" cy="307777"/>
             </a:xfrm>
             <a:prstGeom prst="rect">
               <a:avLst/>
@@ -3302,7 +3225,7 @@
             <a:lstStyle/>
             <a:p>
               <a:r>
-                <a:rPr lang="en-GB" sz="2113" dirty="0">
+                <a:rPr lang="en-GB" sz="1400" dirty="0">
                   <a:latin typeface="CMU Serif" panose="02000603000000000000" pitchFamily="2" charset="0"/>
                   <a:ea typeface="CMU Serif" panose="02000603000000000000" pitchFamily="2" charset="0"/>
                   <a:cs typeface="CMU Serif" panose="02000603000000000000" pitchFamily="2" charset="0"/>
@@ -3320,8 +3243,8 @@
           </p:nvSpPr>
           <p:spPr>
             <a:xfrm>
-              <a:off x="-169288" y="2307360"/>
-              <a:ext cx="664989" cy="629325"/>
+              <a:off x="170695" y="2164579"/>
+              <a:ext cx="352982" cy="307777"/>
             </a:xfrm>
             <a:prstGeom prst="rect">
               <a:avLst/>
@@ -3335,45 +3258,12 @@
             <a:lstStyle/>
             <a:p>
               <a:r>
-                <a:rPr lang="en-GB" sz="2113" dirty="0">
+                <a:rPr lang="en-GB" sz="1400" dirty="0">
                   <a:latin typeface="CMU Serif" panose="02000603000000000000" pitchFamily="2" charset="0"/>
                   <a:ea typeface="CMU Serif" panose="02000603000000000000" pitchFamily="2" charset="0"/>
                   <a:cs typeface="CMU Serif" panose="02000603000000000000" pitchFamily="2" charset="0"/>
                 </a:rPr>
                 <a:t>b)</a:t>
-              </a:r>
-            </a:p>
-          </p:txBody>
-        </p:sp>
-        <p:sp>
-          <p:nvSpPr>
-            <p:cNvPr id="20" name="TextBox 19"/>
-            <p:cNvSpPr txBox="1"/>
-            <p:nvPr/>
-          </p:nvSpPr>
-          <p:spPr>
-            <a:xfrm>
-              <a:off x="-156378" y="4215672"/>
-              <a:ext cx="619080" cy="629325"/>
-            </a:xfrm>
-            <a:prstGeom prst="rect">
-              <a:avLst/>
-            </a:prstGeom>
-            <a:noFill/>
-          </p:spPr>
-          <p:txBody>
-            <a:bodyPr wrap="none" rtlCol="0">
-              <a:spAutoFit/>
-            </a:bodyPr>
-            <a:lstStyle/>
-            <a:p>
-              <a:r>
-                <a:rPr lang="en-GB" sz="2113" dirty="0">
-                  <a:latin typeface="CMU Serif" panose="02000603000000000000" pitchFamily="2" charset="0"/>
-                  <a:ea typeface="CMU Serif" panose="02000603000000000000" pitchFamily="2" charset="0"/>
-                  <a:cs typeface="CMU Serif" panose="02000603000000000000" pitchFamily="2" charset="0"/>
-                </a:rPr>
-                <a:t>c)</a:t>
               </a:r>
             </a:p>
           </p:txBody>
@@ -3386,8 +3276,8 @@
           </p:nvGrpSpPr>
           <p:grpSpPr>
             <a:xfrm>
-              <a:off x="3601867" y="331773"/>
-              <a:ext cx="2370218" cy="2520740"/>
+              <a:off x="2203279" y="250747"/>
+              <a:ext cx="2140609" cy="2276553"/>
               <a:chOff x="762397" y="2973941"/>
               <a:chExt cx="2380979" cy="2726110"/>
             </a:xfrm>
@@ -3401,7 +3291,7 @@
               <p:nvPr/>
             </p:nvPicPr>
             <p:blipFill rotWithShape="1">
-              <a:blip r:embed="rId5" cstate="print">
+              <a:blip r:embed="rId4" cstate="print">
                 <a:extLst>
                   <a:ext uri="{28A0092B-C50C-407E-A947-70E740481C1C}">
                     <a14:useLocalDpi xmlns:a14="http://schemas.microsoft.com/office/drawing/2010/main" val="0"/>
@@ -3478,109 +3368,409 @@
             </p:txBody>
           </p:sp>
         </p:grpSp>
-        <p:grpSp>
-          <p:nvGrpSpPr>
-            <p:cNvPr id="7" name="Group 6"/>
-            <p:cNvGrpSpPr/>
-            <p:nvPr/>
-          </p:nvGrpSpPr>
-          <p:grpSpPr>
-            <a:xfrm>
-              <a:off x="2670714" y="4469328"/>
-              <a:ext cx="2306202" cy="1644675"/>
-              <a:chOff x="8553637" y="3094023"/>
-              <a:chExt cx="2873537" cy="2206212"/>
-            </a:xfrm>
-          </p:grpSpPr>
-          <p:pic>
-            <p:nvPicPr>
-              <p:cNvPr id="16" name="Picture 15"/>
-              <p:cNvPicPr>
-                <a:picLocks noChangeAspect="1"/>
-              </p:cNvPicPr>
-              <p:nvPr/>
-            </p:nvPicPr>
-            <p:blipFill>
-              <a:blip r:embed="rId6"/>
-              <a:stretch>
-                <a:fillRect/>
-              </a:stretch>
-            </p:blipFill>
-            <p:spPr>
-              <a:xfrm>
-                <a:off x="8728204" y="3094023"/>
-                <a:ext cx="2698970" cy="2206212"/>
-              </a:xfrm>
-              <a:prstGeom prst="rect">
-                <a:avLst/>
-              </a:prstGeom>
-            </p:spPr>
-          </p:pic>
-          <p:sp>
-            <p:nvSpPr>
-              <p:cNvPr id="17" name="Rectangle 16"/>
-              <p:cNvSpPr/>
-              <p:nvPr/>
-            </p:nvSpPr>
-            <p:spPr>
-              <a:xfrm>
-                <a:off x="8553637" y="3094023"/>
-                <a:ext cx="349134" cy="349134"/>
-              </a:xfrm>
-              <a:prstGeom prst="rect">
-                <a:avLst/>
-              </a:prstGeom>
-              <a:solidFill>
-                <a:schemeClr val="bg1"/>
-              </a:solidFill>
-              <a:ln>
-                <a:noFill/>
-              </a:ln>
-            </p:spPr>
-            <p:style>
-              <a:lnRef idx="2">
-                <a:schemeClr val="accent1">
-                  <a:shade val="50000"/>
-                </a:schemeClr>
-              </a:lnRef>
-              <a:fillRef idx="1">
-                <a:schemeClr val="accent1"/>
-              </a:fillRef>
-              <a:effectRef idx="0">
-                <a:schemeClr val="accent1"/>
-              </a:effectRef>
-              <a:fontRef idx="minor">
-                <a:schemeClr val="lt1"/>
-              </a:fontRef>
-            </p:style>
-            <p:txBody>
-              <a:bodyPr rtlCol="0" anchor="ctr"/>
-              <a:lstStyle/>
-              <a:p>
-                <a:pPr algn="ctr"/>
-                <a:endParaRPr lang="en-GB" sz="2113" u="sng"/>
-              </a:p>
-            </p:txBody>
-          </p:sp>
-        </p:grpSp>
+      </p:grpSp>
+    </p:spTree>
+    <p:extLst>
+      <p:ext uri="{BB962C8B-B14F-4D97-AF65-F5344CB8AC3E}">
+        <p14:creationId xmlns:p14="http://schemas.microsoft.com/office/powerpoint/2010/main" val="2165141319"/>
+      </p:ext>
+    </p:extLst>
+  </p:cSld>
+  <p:clrMapOvr>
+    <a:masterClrMapping/>
+  </p:clrMapOvr>
+</p:sld>
+</file>
+
+<file path=ppt/slides/slide2.xml><?xml version="1.0" encoding="utf-8"?>
+<p:sld xmlns:a="http://schemas.openxmlformats.org/drawingml/2006/main" xmlns:r="http://schemas.openxmlformats.org/officeDocument/2006/relationships" xmlns:p="http://schemas.openxmlformats.org/presentationml/2006/main">
+  <p:cSld>
+    <p:spTree>
+      <p:nvGrpSpPr>
+        <p:cNvPr id="1" name=""/>
+        <p:cNvGrpSpPr/>
+        <p:nvPr/>
+      </p:nvGrpSpPr>
+      <p:grpSpPr>
+        <a:xfrm>
+          <a:off x="0" y="0"/>
+          <a:ext cx="0" cy="0"/>
+          <a:chOff x="0" y="0"/>
+          <a:chExt cx="0" cy="0"/>
+        </a:xfrm>
+      </p:grpSpPr>
+      <p:grpSp>
+        <p:nvGrpSpPr>
+          <p:cNvPr id="8" name="Group 7"/>
+          <p:cNvGrpSpPr/>
+          <p:nvPr/>
+        </p:nvGrpSpPr>
+        <p:grpSpPr>
+          <a:xfrm>
+            <a:off x="391264" y="193639"/>
+            <a:ext cx="3934784" cy="1633459"/>
+            <a:chOff x="8348257" y="1485049"/>
+            <a:chExt cx="3284297" cy="1467834"/>
+          </a:xfrm>
+        </p:grpSpPr>
         <p:pic>
           <p:nvPicPr>
-            <p:cNvPr id="2" name="Picture 1"/>
+            <p:cNvPr id="14" name="Picture 13"/>
             <p:cNvPicPr>
               <a:picLocks noChangeAspect="1"/>
             </p:cNvPicPr>
             <p:nvPr/>
           </p:nvPicPr>
           <p:blipFill>
-            <a:blip r:embed="rId7"/>
+            <a:blip r:embed="rId2"/>
             <a:stretch>
               <a:fillRect/>
             </a:stretch>
           </p:blipFill>
           <p:spPr>
             <a:xfrm>
-              <a:off x="4854834" y="4483089"/>
-              <a:ext cx="1921907" cy="1630914"/>
+              <a:off x="8522824" y="1599319"/>
+              <a:ext cx="3109730" cy="1353564"/>
+            </a:xfrm>
+            <a:prstGeom prst="rect">
+              <a:avLst/>
+            </a:prstGeom>
+          </p:spPr>
+        </p:pic>
+        <p:sp>
+          <p:nvSpPr>
+            <p:cNvPr id="15" name="Rectangle 14"/>
+            <p:cNvSpPr/>
+            <p:nvPr/>
+          </p:nvSpPr>
+          <p:spPr>
+            <a:xfrm>
+              <a:off x="8348257" y="1485049"/>
+              <a:ext cx="349134" cy="349134"/>
+            </a:xfrm>
+            <a:prstGeom prst="rect">
+              <a:avLst/>
+            </a:prstGeom>
+            <a:solidFill>
+              <a:schemeClr val="bg1"/>
+            </a:solidFill>
+            <a:ln>
+              <a:noFill/>
+            </a:ln>
+          </p:spPr>
+          <p:style>
+            <a:lnRef idx="2">
+              <a:schemeClr val="accent1">
+                <a:shade val="50000"/>
+              </a:schemeClr>
+            </a:lnRef>
+            <a:fillRef idx="1">
+              <a:schemeClr val="accent1"/>
+            </a:fillRef>
+            <a:effectRef idx="0">
+              <a:schemeClr val="accent1"/>
+            </a:effectRef>
+            <a:fontRef idx="minor">
+              <a:schemeClr val="lt1"/>
+            </a:fontRef>
+          </p:style>
+          <p:txBody>
+            <a:bodyPr rtlCol="0" anchor="ctr"/>
+            <a:lstStyle/>
+            <a:p>
+              <a:pPr algn="ctr"/>
+              <a:endParaRPr lang="en-GB" sz="2113"/>
+            </a:p>
+          </p:txBody>
+        </p:sp>
+      </p:grpSp>
+      <p:grpSp>
+        <p:nvGrpSpPr>
+          <p:cNvPr id="7" name="Group 6"/>
+          <p:cNvGrpSpPr/>
+          <p:nvPr/>
+        </p:nvGrpSpPr>
+        <p:grpSpPr>
+          <a:xfrm>
+            <a:off x="51487" y="1855250"/>
+            <a:ext cx="2554446" cy="1821713"/>
+            <a:chOff x="8553637" y="3094023"/>
+            <a:chExt cx="2873537" cy="2206212"/>
+          </a:xfrm>
+        </p:grpSpPr>
+        <p:pic>
+          <p:nvPicPr>
+            <p:cNvPr id="16" name="Picture 15"/>
+            <p:cNvPicPr>
+              <a:picLocks noChangeAspect="1"/>
+            </p:cNvPicPr>
+            <p:nvPr/>
+          </p:nvPicPr>
+          <p:blipFill>
+            <a:blip r:embed="rId3"/>
+            <a:stretch>
+              <a:fillRect/>
+            </a:stretch>
+          </p:blipFill>
+          <p:spPr>
+            <a:xfrm>
+              <a:off x="8728204" y="3094023"/>
+              <a:ext cx="2698970" cy="2206212"/>
+            </a:xfrm>
+            <a:prstGeom prst="rect">
+              <a:avLst/>
+            </a:prstGeom>
+          </p:spPr>
+        </p:pic>
+        <p:sp>
+          <p:nvSpPr>
+            <p:cNvPr id="17" name="Rectangle 16"/>
+            <p:cNvSpPr/>
+            <p:nvPr/>
+          </p:nvSpPr>
+          <p:spPr>
+            <a:xfrm>
+              <a:off x="8553637" y="3094023"/>
+              <a:ext cx="349134" cy="349134"/>
+            </a:xfrm>
+            <a:prstGeom prst="rect">
+              <a:avLst/>
+            </a:prstGeom>
+            <a:solidFill>
+              <a:schemeClr val="bg1"/>
+            </a:solidFill>
+            <a:ln>
+              <a:noFill/>
+            </a:ln>
+          </p:spPr>
+          <p:style>
+            <a:lnRef idx="2">
+              <a:schemeClr val="accent1">
+                <a:shade val="50000"/>
+              </a:schemeClr>
+            </a:lnRef>
+            <a:fillRef idx="1">
+              <a:schemeClr val="accent1"/>
+            </a:fillRef>
+            <a:effectRef idx="0">
+              <a:schemeClr val="accent1"/>
+            </a:effectRef>
+            <a:fontRef idx="minor">
+              <a:schemeClr val="lt1"/>
+            </a:fontRef>
+          </p:style>
+          <p:txBody>
+            <a:bodyPr rtlCol="0" anchor="ctr"/>
+            <a:lstStyle/>
+            <a:p>
+              <a:pPr algn="ctr"/>
+              <a:endParaRPr lang="en-GB" sz="2113" u="sng"/>
+            </a:p>
+          </p:txBody>
+        </p:sp>
+      </p:grpSp>
+      <p:pic>
+        <p:nvPicPr>
+          <p:cNvPr id="2" name="Picture 1"/>
+          <p:cNvPicPr>
+            <a:picLocks noChangeAspect="1"/>
+          </p:cNvPicPr>
+          <p:nvPr/>
+        </p:nvPicPr>
+        <p:blipFill>
+          <a:blip r:embed="rId4"/>
+          <a:stretch>
+            <a:fillRect/>
+          </a:stretch>
+        </p:blipFill>
+        <p:spPr>
+          <a:xfrm>
+            <a:off x="2479739" y="1887444"/>
+            <a:ext cx="2128784" cy="1806470"/>
+          </a:xfrm>
+          <a:prstGeom prst="rect">
+            <a:avLst/>
+          </a:prstGeom>
+        </p:spPr>
+      </p:pic>
+      <p:sp>
+        <p:nvSpPr>
+          <p:cNvPr id="34" name="Rectangle 33"/>
+          <p:cNvSpPr/>
+          <p:nvPr/>
+        </p:nvSpPr>
+        <p:spPr>
+          <a:xfrm>
+            <a:off x="3503637" y="3004683"/>
+            <a:ext cx="80988" cy="153401"/>
+          </a:xfrm>
+          <a:prstGeom prst="rect">
+            <a:avLst/>
+          </a:prstGeom>
+          <a:solidFill>
+            <a:schemeClr val="bg1"/>
+          </a:solidFill>
+          <a:ln>
+            <a:noFill/>
+          </a:ln>
+        </p:spPr>
+        <p:style>
+          <a:lnRef idx="2">
+            <a:schemeClr val="accent1">
+              <a:shade val="50000"/>
+            </a:schemeClr>
+          </a:lnRef>
+          <a:fillRef idx="1">
+            <a:schemeClr val="accent1"/>
+          </a:fillRef>
+          <a:effectRef idx="0">
+            <a:schemeClr val="accent1"/>
+          </a:effectRef>
+          <a:fontRef idx="minor">
+            <a:schemeClr val="lt1"/>
+          </a:fontRef>
+        </p:style>
+        <p:txBody>
+          <a:bodyPr rtlCol="0" anchor="ctr"/>
+          <a:lstStyle/>
+          <a:p>
+            <a:pPr algn="ctr"/>
+            <a:endParaRPr lang="en-GB"/>
+          </a:p>
+        </p:txBody>
+      </p:sp>
+    </p:spTree>
+    <p:extLst>
+      <p:ext uri="{BB962C8B-B14F-4D97-AF65-F5344CB8AC3E}">
+        <p14:creationId xmlns:p14="http://schemas.microsoft.com/office/powerpoint/2010/main" val="2346000024"/>
+      </p:ext>
+    </p:extLst>
+  </p:cSld>
+  <p:clrMapOvr>
+    <a:masterClrMapping/>
+  </p:clrMapOvr>
+</p:sld>
+</file>
+
+<file path=ppt/slides/slide3.xml><?xml version="1.0" encoding="utf-8"?>
+<p:sld xmlns:a="http://schemas.openxmlformats.org/drawingml/2006/main" xmlns:r="http://schemas.openxmlformats.org/officeDocument/2006/relationships" xmlns:p="http://schemas.openxmlformats.org/presentationml/2006/main">
+  <p:cSld>
+    <p:spTree>
+      <p:nvGrpSpPr>
+        <p:cNvPr id="1" name=""/>
+        <p:cNvGrpSpPr/>
+        <p:nvPr/>
+      </p:nvGrpSpPr>
+      <p:grpSpPr>
+        <a:xfrm>
+          <a:off x="0" y="0"/>
+          <a:ext cx="0" cy="0"/>
+          <a:chOff x="0" y="0"/>
+          <a:chExt cx="0" cy="0"/>
+        </a:xfrm>
+      </p:grpSpPr>
+      <p:pic>
+        <p:nvPicPr>
+          <p:cNvPr id="28" name="Picture 27"/>
+          <p:cNvPicPr>
+            <a:picLocks noChangeAspect="1"/>
+          </p:cNvPicPr>
+          <p:nvPr/>
+        </p:nvPicPr>
+        <p:blipFill>
+          <a:blip r:embed="rId2"/>
+          <a:stretch>
+            <a:fillRect/>
+          </a:stretch>
+        </p:blipFill>
+        <p:spPr>
+          <a:xfrm>
+            <a:off x="1595189" y="320573"/>
+            <a:ext cx="1849934" cy="1533626"/>
+          </a:xfrm>
+          <a:prstGeom prst="rect">
+            <a:avLst/>
+          </a:prstGeom>
+        </p:spPr>
+      </p:pic>
+      <p:sp>
+        <p:nvSpPr>
+          <p:cNvPr id="34" name="Rectangle 33"/>
+          <p:cNvSpPr/>
+          <p:nvPr/>
+        </p:nvSpPr>
+        <p:spPr>
+          <a:xfrm>
+            <a:off x="3503637" y="3004683"/>
+            <a:ext cx="80988" cy="153401"/>
+          </a:xfrm>
+          <a:prstGeom prst="rect">
+            <a:avLst/>
+          </a:prstGeom>
+          <a:solidFill>
+            <a:schemeClr val="bg1"/>
+          </a:solidFill>
+          <a:ln>
+            <a:noFill/>
+          </a:ln>
+        </p:spPr>
+        <p:style>
+          <a:lnRef idx="2">
+            <a:schemeClr val="accent1">
+              <a:shade val="50000"/>
+            </a:schemeClr>
+          </a:lnRef>
+          <a:fillRef idx="1">
+            <a:schemeClr val="accent1"/>
+          </a:fillRef>
+          <a:effectRef idx="0">
+            <a:schemeClr val="accent1"/>
+          </a:effectRef>
+          <a:fontRef idx="minor">
+            <a:schemeClr val="lt1"/>
+          </a:fontRef>
+        </p:style>
+        <p:txBody>
+          <a:bodyPr rtlCol="0" anchor="ctr"/>
+          <a:lstStyle/>
+          <a:p>
+            <a:pPr algn="ctr"/>
+            <a:endParaRPr lang="en-GB"/>
+          </a:p>
+        </p:txBody>
+      </p:sp>
+      <p:grpSp>
+        <p:nvGrpSpPr>
+          <p:cNvPr id="37" name="Group 36"/>
+          <p:cNvGrpSpPr/>
+          <p:nvPr/>
+        </p:nvGrpSpPr>
+        <p:grpSpPr>
+          <a:xfrm>
+            <a:off x="524911" y="1943110"/>
+            <a:ext cx="3839146" cy="1985423"/>
+            <a:chOff x="2791022" y="6252699"/>
+            <a:chExt cx="4066226" cy="2102856"/>
+          </a:xfrm>
+        </p:grpSpPr>
+        <p:pic>
+          <p:nvPicPr>
+            <p:cNvPr id="32" name="Picture 31"/>
+            <p:cNvPicPr>
+              <a:picLocks noChangeAspect="1"/>
+            </p:cNvPicPr>
+            <p:nvPr/>
+          </p:nvPicPr>
+          <p:blipFill>
+            <a:blip r:embed="rId3"/>
+            <a:stretch>
+              <a:fillRect/>
+            </a:stretch>
+          </p:blipFill>
+          <p:spPr>
+            <a:xfrm>
+              <a:off x="2791022" y="6295135"/>
+              <a:ext cx="2028148" cy="2060420"/>
             </a:xfrm>
             <a:prstGeom prst="rect">
               <a:avLst/>
@@ -3589,22 +3779,22 @@
         </p:pic>
         <p:pic>
           <p:nvPicPr>
-            <p:cNvPr id="28" name="Picture 27"/>
+            <p:cNvPr id="33" name="Picture 32"/>
             <p:cNvPicPr>
               <a:picLocks noChangeAspect="1"/>
             </p:cNvPicPr>
             <p:nvPr/>
           </p:nvPicPr>
           <p:blipFill>
-            <a:blip r:embed="rId8"/>
+            <a:blip r:embed="rId4"/>
             <a:stretch>
               <a:fillRect/>
             </a:stretch>
           </p:blipFill>
           <p:spPr>
             <a:xfrm>
-              <a:off x="428025" y="6295135"/>
-              <a:ext cx="2296589" cy="1903909"/>
+              <a:off x="4819170" y="6295135"/>
+              <a:ext cx="2038078" cy="2060420"/>
             </a:xfrm>
             <a:prstGeom prst="rect">
               <a:avLst/>
@@ -3613,51 +3803,13 @@
         </p:pic>
         <p:sp>
           <p:nvSpPr>
-            <p:cNvPr id="29" name="TextBox 28"/>
-            <p:cNvSpPr txBox="1"/>
-            <p:nvPr/>
-          </p:nvSpPr>
-          <p:spPr>
-            <a:xfrm>
-              <a:off x="-169294" y="6014199"/>
-              <a:ext cx="664989" cy="629325"/>
-            </a:xfrm>
-            <a:prstGeom prst="rect">
-              <a:avLst/>
-            </a:prstGeom>
-            <a:noFill/>
-          </p:spPr>
-          <p:txBody>
-            <a:bodyPr wrap="none" rtlCol="0">
-              <a:spAutoFit/>
-            </a:bodyPr>
-            <a:lstStyle/>
-            <a:p>
-              <a:r>
-                <a:rPr lang="en-GB" sz="2113" dirty="0">
-                  <a:latin typeface="CMU Serif" panose="02000603000000000000" pitchFamily="2" charset="0"/>
-                  <a:ea typeface="CMU Serif" panose="02000603000000000000" pitchFamily="2" charset="0"/>
-                  <a:cs typeface="CMU Serif" panose="02000603000000000000" pitchFamily="2" charset="0"/>
-                </a:rPr>
-                <a:t>d)</a:t>
-              </a:r>
-              <a:endParaRPr lang="en-GB" sz="2113" dirty="0">
-                <a:latin typeface="CMU Serif" panose="02000603000000000000" pitchFamily="2" charset="0"/>
-                <a:ea typeface="CMU Serif" panose="02000603000000000000" pitchFamily="2" charset="0"/>
-                <a:cs typeface="CMU Serif" panose="02000603000000000000" pitchFamily="2" charset="0"/>
-              </a:endParaRPr>
-            </a:p>
-          </p:txBody>
-        </p:sp>
-        <p:sp>
-          <p:nvSpPr>
-            <p:cNvPr id="34" name="Rectangle 33"/>
+            <p:cNvPr id="35" name="Rectangle 34"/>
             <p:cNvSpPr/>
             <p:nvPr/>
           </p:nvSpPr>
           <p:spPr>
             <a:xfrm>
-              <a:off x="4854834" y="4483089"/>
+              <a:off x="2851776" y="6252699"/>
               <a:ext cx="122082" cy="231239"/>
             </a:xfrm>
             <a:prstGeom prst="rect">
@@ -3695,161 +3847,52 @@
             </a:p>
           </p:txBody>
         </p:sp>
-        <p:grpSp>
-          <p:nvGrpSpPr>
-            <p:cNvPr id="37" name="Group 36"/>
-            <p:cNvGrpSpPr/>
+        <p:sp>
+          <p:nvSpPr>
+            <p:cNvPr id="36" name="Rectangle 35"/>
+            <p:cNvSpPr/>
             <p:nvPr/>
-          </p:nvGrpSpPr>
-          <p:grpSpPr>
+          </p:nvSpPr>
+          <p:spPr>
             <a:xfrm>
-              <a:off x="2791022" y="6252699"/>
-              <a:ext cx="4066226" cy="2102856"/>
-              <a:chOff x="2791022" y="6252699"/>
-              <a:chExt cx="4066226" cy="2102856"/>
+              <a:off x="4825197" y="6295135"/>
+              <a:ext cx="122082" cy="231239"/>
             </a:xfrm>
-          </p:grpSpPr>
-          <p:pic>
-            <p:nvPicPr>
-              <p:cNvPr id="32" name="Picture 31"/>
-              <p:cNvPicPr>
-                <a:picLocks noChangeAspect="1"/>
-              </p:cNvPicPr>
-              <p:nvPr/>
-            </p:nvPicPr>
-            <p:blipFill>
-              <a:blip r:embed="rId9"/>
-              <a:stretch>
-                <a:fillRect/>
-              </a:stretch>
-            </p:blipFill>
-            <p:spPr>
-              <a:xfrm>
-                <a:off x="2791022" y="6295135"/>
-                <a:ext cx="2028148" cy="2060420"/>
-              </a:xfrm>
-              <a:prstGeom prst="rect">
-                <a:avLst/>
-              </a:prstGeom>
-            </p:spPr>
-          </p:pic>
-          <p:pic>
-            <p:nvPicPr>
-              <p:cNvPr id="33" name="Picture 32"/>
-              <p:cNvPicPr>
-                <a:picLocks noChangeAspect="1"/>
-              </p:cNvPicPr>
-              <p:nvPr/>
-            </p:nvPicPr>
-            <p:blipFill>
-              <a:blip r:embed="rId10"/>
-              <a:stretch>
-                <a:fillRect/>
-              </a:stretch>
-            </p:blipFill>
-            <p:spPr>
-              <a:xfrm>
-                <a:off x="4819170" y="6295135"/>
-                <a:ext cx="2038078" cy="2060420"/>
-              </a:xfrm>
-              <a:prstGeom prst="rect">
-                <a:avLst/>
-              </a:prstGeom>
-            </p:spPr>
-          </p:pic>
-          <p:sp>
-            <p:nvSpPr>
-              <p:cNvPr id="35" name="Rectangle 34"/>
-              <p:cNvSpPr/>
-              <p:nvPr/>
-            </p:nvSpPr>
-            <p:spPr>
-              <a:xfrm>
-                <a:off x="2851776" y="6252699"/>
-                <a:ext cx="122082" cy="231239"/>
-              </a:xfrm>
-              <a:prstGeom prst="rect">
-                <a:avLst/>
-              </a:prstGeom>
-              <a:solidFill>
-                <a:schemeClr val="bg1"/>
-              </a:solidFill>
-              <a:ln>
-                <a:noFill/>
-              </a:ln>
-            </p:spPr>
-            <p:style>
-              <a:lnRef idx="2">
-                <a:schemeClr val="accent1">
-                  <a:shade val="50000"/>
-                </a:schemeClr>
-              </a:lnRef>
-              <a:fillRef idx="1">
-                <a:schemeClr val="accent1"/>
-              </a:fillRef>
-              <a:effectRef idx="0">
-                <a:schemeClr val="accent1"/>
-              </a:effectRef>
-              <a:fontRef idx="minor">
-                <a:schemeClr val="lt1"/>
-              </a:fontRef>
-            </p:style>
-            <p:txBody>
-              <a:bodyPr rtlCol="0" anchor="ctr"/>
-              <a:lstStyle/>
-              <a:p>
-                <a:pPr algn="ctr"/>
-                <a:endParaRPr lang="en-GB"/>
-              </a:p>
-            </p:txBody>
-          </p:sp>
-          <p:sp>
-            <p:nvSpPr>
-              <p:cNvPr id="36" name="Rectangle 35"/>
-              <p:cNvSpPr/>
-              <p:nvPr/>
-            </p:nvSpPr>
-            <p:spPr>
-              <a:xfrm>
-                <a:off x="4825197" y="6295135"/>
-                <a:ext cx="122082" cy="231239"/>
-              </a:xfrm>
-              <a:prstGeom prst="rect">
-                <a:avLst/>
-              </a:prstGeom>
-              <a:solidFill>
-                <a:schemeClr val="bg1"/>
-              </a:solidFill>
-              <a:ln>
-                <a:noFill/>
-              </a:ln>
-            </p:spPr>
-            <p:style>
-              <a:lnRef idx="2">
-                <a:schemeClr val="accent1">
-                  <a:shade val="50000"/>
-                </a:schemeClr>
-              </a:lnRef>
-              <a:fillRef idx="1">
-                <a:schemeClr val="accent1"/>
-              </a:fillRef>
-              <a:effectRef idx="0">
-                <a:schemeClr val="accent1"/>
-              </a:effectRef>
-              <a:fontRef idx="minor">
-                <a:schemeClr val="lt1"/>
-              </a:fontRef>
-            </p:style>
-            <p:txBody>
-              <a:bodyPr rtlCol="0" anchor="ctr"/>
-              <a:lstStyle/>
-              <a:p>
-                <a:pPr algn="ctr"/>
-                <a:endParaRPr lang="en-GB"/>
-              </a:p>
-            </p:txBody>
-          </p:sp>
-        </p:grpSp>
+            <a:prstGeom prst="rect">
+              <a:avLst/>
+            </a:prstGeom>
+            <a:solidFill>
+              <a:schemeClr val="bg1"/>
+            </a:solidFill>
+            <a:ln>
+              <a:noFill/>
+            </a:ln>
+          </p:spPr>
+          <p:style>
+            <a:lnRef idx="2">
+              <a:schemeClr val="accent1">
+                <a:shade val="50000"/>
+              </a:schemeClr>
+            </a:lnRef>
+            <a:fillRef idx="1">
+              <a:schemeClr val="accent1"/>
+            </a:fillRef>
+            <a:effectRef idx="0">
+              <a:schemeClr val="accent1"/>
+            </a:effectRef>
+            <a:fontRef idx="minor">
+              <a:schemeClr val="lt1"/>
+            </a:fontRef>
+          </p:style>
+          <p:txBody>
+            <a:bodyPr rtlCol="0" anchor="ctr"/>
+            <a:lstStyle/>
+            <a:p>
+              <a:pPr algn="ctr"/>
+              <a:endParaRPr lang="en-GB"/>
+            </a:p>
+          </p:txBody>
+        </p:sp>
       </p:grpSp>
     </p:spTree>
     <p:extLst>
@@ -3861,13 +3904,6 @@
   <p:clrMapOvr>
     <a:masterClrMapping/>
   </p:clrMapOvr>
-  <p:timing>
-    <p:tnLst>
-      <p:par>
-        <p:cTn id="1" dur="indefinite" restart="never" nodeType="tmRoot"/>
-      </p:par>
-    </p:tnLst>
-  </p:timing>
 </p:sld>
 </file>
 

</xml_diff>